<commit_message>
feat: embed real live chat interface on Slide 5 AI copilot presentation
</commit_message>
<xml_diff>
--- a/public/proposal/Goldfields-BastionGroup-Executive-Deck.pptx
+++ b/public/proposal/Goldfields-BastionGroup-Executive-Deck.pptx
@@ -12883,7 +12883,7 @@
             </a:avLst>
           </a:prstGeom>
           <a:solidFill>
-            <a:srgbClr val="103A62"/>
+            <a:srgbClr val="0B3052"/>
           </a:solidFill>
           <a:ln w="19050">
             <a:solidFill>
@@ -12921,8 +12921,8 @@
         </p:nvSpPr>
         <p:spPr>
           <a:xfrm>
-            <a:off x="6446520" y="1554480"/>
-            <a:ext cx="4754880" cy="4160520"/>
+            <a:off x="6400800" y="1508760"/>
+            <a:ext cx="4846320" cy="365760"/>
           </a:xfrm>
           <a:prstGeom prst="rect">
             <a:avLst/>
@@ -12944,15 +12944,304 @@
               </a:defRPr>
             </a:pPr>
             <a:r>
-              <a:t>COPILOT INTERACTION SIMULATION</a:t>
+              <a:t>REAL COPILOT INTERACTION: LIVE VERIFIED RESPONSE</a:t>
+            </a:r>
+          </a:p>
+        </p:txBody>
+      </p:sp>
+      <p:pic>
+        <p:nvPicPr>
+          <p:cNvPr id="11" name="Picture 10" descr="chat_crop_q_and_a.png"/>
+          <p:cNvPicPr>
+            <a:picLocks noChangeAspect="1"/>
+          </p:cNvPicPr>
+          <p:nvPr/>
+        </p:nvPicPr>
+        <p:blipFill>
+          <a:blip r:embed="rId3"/>
+          <a:stretch>
+            <a:fillRect/>
+          </a:stretch>
+        </p:blipFill>
+        <p:spPr>
+          <a:xfrm>
+            <a:off x="6400800" y="1938528"/>
+            <a:ext cx="2600130" cy="3822191"/>
+          </a:xfrm>
+          <a:prstGeom prst="rect">
+            <a:avLst/>
+          </a:prstGeom>
+        </p:spPr>
+      </p:pic>
+      <p:sp>
+        <p:nvSpPr>
+          <p:cNvPr id="12" name="Rounded Rectangle 11"/>
+          <p:cNvSpPr/>
+          <p:nvPr/>
+        </p:nvSpPr>
+        <p:spPr>
+          <a:xfrm>
+            <a:off x="9098280" y="1938528"/>
+            <a:ext cx="2176272" cy="877824"/>
+          </a:xfrm>
+          <a:prstGeom prst="roundRect">
+            <a:avLst>
+              <a:gd name="adj" fmla="val 10416"/>
+            </a:avLst>
+          </a:prstGeom>
+          <a:solidFill>
+            <a:srgbClr val="103A62"/>
+          </a:solidFill>
+          <a:ln w="12700">
+            <a:solidFill>
+              <a:srgbClr val="1A4B75"/>
+            </a:solidFill>
+          </a:ln>
+        </p:spPr>
+        <p:style>
+          <a:lnRef idx="1">
+            <a:schemeClr val="accent1"/>
+          </a:lnRef>
+          <a:fillRef idx="3">
+            <a:schemeClr val="accent1"/>
+          </a:fillRef>
+          <a:effectRef idx="2">
+            <a:schemeClr val="accent1"/>
+          </a:effectRef>
+          <a:fontRef idx="minor">
+            <a:schemeClr val="lt1"/>
+          </a:fontRef>
+        </p:style>
+        <p:txBody>
+          <a:bodyPr rtlCol="0" anchor="ctr"/>
+          <a:lstStyle/>
+          <a:p>
+            <a:pPr algn="ctr"/>
+          </a:p>
+        </p:txBody>
+      </p:sp>
+      <p:sp>
+        <p:nvSpPr>
+          <p:cNvPr id="13" name="TextBox 12"/>
+          <p:cNvSpPr txBox="1"/>
+          <p:nvPr/>
+        </p:nvSpPr>
+        <p:spPr>
+          <a:xfrm>
+            <a:off x="9217152" y="2011680"/>
+            <a:ext cx="1938528" cy="731520"/>
+          </a:xfrm>
+          <a:prstGeom prst="rect">
+            <a:avLst/>
+          </a:prstGeom>
+          <a:noFill/>
+        </p:spPr>
+        <p:txBody>
+          <a:bodyPr wrap="square" lIns="0" tIns="0" bIns="0" rIns="0">
+            <a:spAutoFit/>
+          </a:bodyPr>
+          <a:lstStyle/>
+          <a:p>
+            <a:pPr>
+              <a:defRPr sz="750" b="1">
+                <a:solidFill>
+                  <a:srgbClr val="00E5C0"/>
+                </a:solidFill>
+                <a:latin typeface="Arial"/>
+              </a:defRPr>
+            </a:pPr>
+            <a:r>
+              <a:t>DETERMINISTIC LLM GROUNDING</a:t>
             </a:r>
           </a:p>
           <a:p>
             <a:pPr>
               <a:spcBef>
-                <a:spcPts val="600"/>
+                <a:spcPts val="100"/>
               </a:spcBef>
-              <a:defRPr sz="850" b="1">
+              <a:defRPr sz="700">
+                <a:solidFill>
+                  <a:srgbClr val="AABED2"/>
+                </a:solidFill>
+                <a:latin typeface="Arial"/>
+              </a:defRPr>
+            </a:pPr>
+            <a:r>
+              <a:t>Constrained strictly to audited annual reports; zero generative drift or hallucination.</a:t>
+            </a:r>
+          </a:p>
+        </p:txBody>
+      </p:sp>
+      <p:sp>
+        <p:nvSpPr>
+          <p:cNvPr id="14" name="Rounded Rectangle 13"/>
+          <p:cNvSpPr/>
+          <p:nvPr/>
+        </p:nvSpPr>
+        <p:spPr>
+          <a:xfrm>
+            <a:off x="9098280" y="2889504"/>
+            <a:ext cx="2176272" cy="877824"/>
+          </a:xfrm>
+          <a:prstGeom prst="roundRect">
+            <a:avLst>
+              <a:gd name="adj" fmla="val 10416"/>
+            </a:avLst>
+          </a:prstGeom>
+          <a:solidFill>
+            <a:srgbClr val="103A62"/>
+          </a:solidFill>
+          <a:ln w="12700">
+            <a:solidFill>
+              <a:srgbClr val="1A4B75"/>
+            </a:solidFill>
+          </a:ln>
+        </p:spPr>
+        <p:style>
+          <a:lnRef idx="1">
+            <a:schemeClr val="accent1"/>
+          </a:lnRef>
+          <a:fillRef idx="3">
+            <a:schemeClr val="accent1"/>
+          </a:fillRef>
+          <a:effectRef idx="2">
+            <a:schemeClr val="accent1"/>
+          </a:effectRef>
+          <a:fontRef idx="minor">
+            <a:schemeClr val="lt1"/>
+          </a:fontRef>
+        </p:style>
+        <p:txBody>
+          <a:bodyPr rtlCol="0" anchor="ctr"/>
+          <a:lstStyle/>
+          <a:p>
+            <a:pPr algn="ctr"/>
+          </a:p>
+        </p:txBody>
+      </p:sp>
+      <p:sp>
+        <p:nvSpPr>
+          <p:cNvPr id="15" name="TextBox 14"/>
+          <p:cNvSpPr txBox="1"/>
+          <p:nvPr/>
+        </p:nvSpPr>
+        <p:spPr>
+          <a:xfrm>
+            <a:off x="9217152" y="2962656"/>
+            <a:ext cx="1938528" cy="731520"/>
+          </a:xfrm>
+          <a:prstGeom prst="rect">
+            <a:avLst/>
+          </a:prstGeom>
+          <a:noFill/>
+        </p:spPr>
+        <p:txBody>
+          <a:bodyPr wrap="square" lIns="0" tIns="0" bIns="0" rIns="0">
+            <a:spAutoFit/>
+          </a:bodyPr>
+          <a:lstStyle/>
+          <a:p>
+            <a:pPr>
+              <a:defRPr sz="750" b="1">
+                <a:solidFill>
+                  <a:srgbClr val="C8A064"/>
+                </a:solidFill>
+                <a:latin typeface="Arial"/>
+              </a:defRPr>
+            </a:pPr>
+            <a:r>
+              <a:t>PAGE-LEVEL CITATIONS</a:t>
+            </a:r>
+          </a:p>
+          <a:p>
+            <a:pPr>
+              <a:spcBef>
+                <a:spcPts val="100"/>
+              </a:spcBef>
+              <a:defRPr sz="700">
+                <a:solidFill>
+                  <a:srgbClr val="AABED2"/>
+                </a:solidFill>
+                <a:latin typeface="Arial"/>
+              </a:defRPr>
+            </a:pPr>
+            <a:r>
+              <a:t>Clickable citations link directly to primary PDF source pages for regulatory verification.</a:t>
+            </a:r>
+          </a:p>
+        </p:txBody>
+      </p:sp>
+      <p:sp>
+        <p:nvSpPr>
+          <p:cNvPr id="16" name="Rounded Rectangle 15"/>
+          <p:cNvSpPr/>
+          <p:nvPr/>
+        </p:nvSpPr>
+        <p:spPr>
+          <a:xfrm>
+            <a:off x="9098280" y="3840480"/>
+            <a:ext cx="2176272" cy="877824"/>
+          </a:xfrm>
+          <a:prstGeom prst="roundRect">
+            <a:avLst>
+              <a:gd name="adj" fmla="val 10416"/>
+            </a:avLst>
+          </a:prstGeom>
+          <a:solidFill>
+            <a:srgbClr val="103A62"/>
+          </a:solidFill>
+          <a:ln w="12700">
+            <a:solidFill>
+              <a:srgbClr val="1A4B75"/>
+            </a:solidFill>
+          </a:ln>
+        </p:spPr>
+        <p:style>
+          <a:lnRef idx="1">
+            <a:schemeClr val="accent1"/>
+          </a:lnRef>
+          <a:fillRef idx="3">
+            <a:schemeClr val="accent1"/>
+          </a:fillRef>
+          <a:effectRef idx="2">
+            <a:schemeClr val="accent1"/>
+          </a:effectRef>
+          <a:fontRef idx="minor">
+            <a:schemeClr val="lt1"/>
+          </a:fontRef>
+        </p:style>
+        <p:txBody>
+          <a:bodyPr rtlCol="0" anchor="ctr"/>
+          <a:lstStyle/>
+          <a:p>
+            <a:pPr algn="ctr"/>
+          </a:p>
+        </p:txBody>
+      </p:sp>
+      <p:sp>
+        <p:nvSpPr>
+          <p:cNvPr id="17" name="TextBox 16"/>
+          <p:cNvSpPr txBox="1"/>
+          <p:nvPr/>
+        </p:nvSpPr>
+        <p:spPr>
+          <a:xfrm>
+            <a:off x="9217152" y="3913632"/>
+            <a:ext cx="1938528" cy="731520"/>
+          </a:xfrm>
+          <a:prstGeom prst="rect">
+            <a:avLst/>
+          </a:prstGeom>
+          <a:noFill/>
+        </p:spPr>
+        <p:txBody>
+          <a:bodyPr wrap="square" lIns="0" tIns="0" bIns="0" rIns="0">
+            <a:spAutoFit/>
+          </a:bodyPr>
+          <a:lstStyle/>
+          <a:p>
+            <a:pPr>
+              <a:defRPr sz="750" b="1">
                 <a:solidFill>
                   <a:srgbClr val="00E5C0"/>
                 </a:solidFill>
@@ -12960,110 +13249,129 @@
               </a:defRPr>
             </a:pPr>
             <a:r>
-              <a:t>Investor Query:</a:t>
+              <a:t>DYNAMIC ACTION DEEP-LINKS</a:t>
             </a:r>
           </a:p>
           <a:p>
             <a:pPr>
               <a:spcBef>
-                <a:spcPts val="200"/>
+                <a:spcPts val="100"/>
               </a:spcBef>
-              <a:defRPr sz="950" i="1">
+              <a:defRPr sz="700">
+                <a:solidFill>
+                  <a:srgbClr val="AABED2"/>
+                </a:solidFill>
+                <a:latin typeface="Arial"/>
+              </a:defRPr>
+            </a:pPr>
+            <a:r>
+              <a:t>One-click routing to the relevant asset profile and live operational telemetry drawer.</a:t>
+            </a:r>
+          </a:p>
+        </p:txBody>
+      </p:sp>
+      <p:sp>
+        <p:nvSpPr>
+          <p:cNvPr id="18" name="Rounded Rectangle 17"/>
+          <p:cNvSpPr/>
+          <p:nvPr/>
+        </p:nvSpPr>
+        <p:spPr>
+          <a:xfrm>
+            <a:off x="9098280" y="4791456"/>
+            <a:ext cx="2176272" cy="877824"/>
+          </a:xfrm>
+          <a:prstGeom prst="roundRect">
+            <a:avLst>
+              <a:gd name="adj" fmla="val 10416"/>
+            </a:avLst>
+          </a:prstGeom>
+          <a:solidFill>
+            <a:srgbClr val="103A62"/>
+          </a:solidFill>
+          <a:ln w="12700">
+            <a:solidFill>
+              <a:srgbClr val="1A4B75"/>
+            </a:solidFill>
+          </a:ln>
+        </p:spPr>
+        <p:style>
+          <a:lnRef idx="1">
+            <a:schemeClr val="accent1"/>
+          </a:lnRef>
+          <a:fillRef idx="3">
+            <a:schemeClr val="accent1"/>
+          </a:fillRef>
+          <a:effectRef idx="2">
+            <a:schemeClr val="accent1"/>
+          </a:effectRef>
+          <a:fontRef idx="minor">
+            <a:schemeClr val="lt1"/>
+          </a:fontRef>
+        </p:style>
+        <p:txBody>
+          <a:bodyPr rtlCol="0" anchor="ctr"/>
+          <a:lstStyle/>
+          <a:p>
+            <a:pPr algn="ctr"/>
+          </a:p>
+        </p:txBody>
+      </p:sp>
+      <p:sp>
+        <p:nvSpPr>
+          <p:cNvPr id="19" name="TextBox 18"/>
+          <p:cNvSpPr txBox="1"/>
+          <p:nvPr/>
+        </p:nvSpPr>
+        <p:spPr>
+          <a:xfrm>
+            <a:off x="9217152" y="4864608"/>
+            <a:ext cx="1938528" cy="731520"/>
+          </a:xfrm>
+          <a:prstGeom prst="rect">
+            <a:avLst/>
+          </a:prstGeom>
+          <a:noFill/>
+        </p:spPr>
+        <p:txBody>
+          <a:bodyPr wrap="square" lIns="0" tIns="0" bIns="0" rIns="0">
+            <a:spAutoFit/>
+          </a:bodyPr>
+          <a:lstStyle/>
+          <a:p>
+            <a:pPr>
+              <a:defRPr sz="750" b="1">
                 <a:solidFill>
                   <a:srgbClr val="FFFFFF"/>
                 </a:solidFill>
-                <a:latin typeface="Georgia"/>
-              </a:defRPr>
-            </a:pPr>
-            <a:r>
-              <a:t>"What is Gold Fields' progress on 2030 decarbonization and what is South Deep's solar plant contribution?"</a:t>
+                <a:latin typeface="Arial"/>
+              </a:defRPr>
+            </a:pPr>
+            <a:r>
+              <a:t>ENTERPRISE AUDIT TRAIL</a:t>
             </a:r>
           </a:p>
           <a:p>
             <a:pPr>
               <a:spcBef>
-                <a:spcPts val="800"/>
+                <a:spcPts val="100"/>
               </a:spcBef>
-              <a:defRPr sz="850" b="1">
-                <a:solidFill>
-                  <a:srgbClr val="C8A064"/>
-                </a:solidFill>
-                <a:latin typeface="Arial"/>
-              </a:defRPr>
-            </a:pPr>
-            <a:r>
-              <a:t>Copilot Verified Response:</a:t>
-            </a:r>
-          </a:p>
-          <a:p>
-            <a:pPr>
-              <a:spcBef>
-                <a:spcPts val="300"/>
-              </a:spcBef>
-              <a:defRPr sz="750">
-                <a:solidFill>
-                  <a:srgbClr val="FFFFFF"/>
-                </a:solidFill>
-                <a:latin typeface="Arial"/>
-              </a:defRPr>
-            </a:pPr>
-            <a:r>
-              <a:t>1. Decarbonization Roadmap: Gold Fields is tracking toward a 30% absolute reduction in Scope 1 &amp; 2 emissions by 2030 (from 2016 baseline) and net-zero by 2050.</a:t>
-            </a:r>
-          </a:p>
-          <a:p>
-            <a:pPr>
-              <a:spcBef>
-                <a:spcPts val="300"/>
-              </a:spcBef>
-              <a:defRPr sz="750">
-                <a:solidFill>
-                  <a:srgbClr val="FFFFFF"/>
-                </a:solidFill>
-                <a:latin typeface="Arial"/>
-              </a:defRPr>
-            </a:pPr>
-            <a:r>
-              <a:t>2. Khanyisa Solar Plant: South Deep's 50MW solar facility generates ~100GWh/year, supplying 24% of the mine's electricity and offsetting 110,000 tonnes of CO2e annually.</a:t>
-            </a:r>
-          </a:p>
-          <a:p>
-            <a:pPr>
-              <a:spcBef>
-                <a:spcPts val="300"/>
-              </a:spcBef>
-              <a:defRPr sz="750">
-                <a:solidFill>
-                  <a:srgbClr val="FFFFFF"/>
-                </a:solidFill>
-                <a:latin typeface="Arial"/>
-              </a:defRPr>
-            </a:pPr>
-            <a:r>
-              <a:t>3. Australian Microgrids: Agnew (hybrid wind/solar/battery) and Granny Smith solar microgrids pushed group renewable electricity generation to 54% in H1 2026.</a:t>
-            </a:r>
-          </a:p>
-          <a:p>
-            <a:pPr>
-              <a:spcBef>
-                <a:spcPts val="600"/>
-              </a:spcBef>
-              <a:defRPr sz="700" b="1">
-                <a:solidFill>
-                  <a:srgbClr val="00E5C0"/>
-                </a:solidFill>
-                <a:latin typeface="Arial"/>
-              </a:defRPr>
-            </a:pPr>
-            <a:r>
-              <a:t>Verified Citations: [Climate Change Report 2025, pp. 24-28] • [H1 2026 Disclosures, p. 12] • [South Deep Technical Bulletin 2026]</a:t>
-            </a:r>
-          </a:p>
-        </p:txBody>
-      </p:sp>
-      <p:sp>
-        <p:nvSpPr>
-          <p:cNvPr id="11" name="Rectangle 10"/>
+              <a:defRPr sz="700">
+                <a:solidFill>
+                  <a:srgbClr val="AABED2"/>
+                </a:solidFill>
+                <a:latin typeface="Arial"/>
+              </a:defRPr>
+            </a:pPr>
+            <a:r>
+              <a:t>Every query, citation, and session token is cryptographically logged for compliance.</a:t>
+            </a:r>
+          </a:p>
+        </p:txBody>
+      </p:sp>
+      <p:sp>
+        <p:nvSpPr>
+          <p:cNvPr id="20" name="Rectangle 19"/>
           <p:cNvSpPr/>
           <p:nvPr/>
         </p:nvSpPr>
@@ -13106,7 +13414,7 @@
       </p:sp>
       <p:sp>
         <p:nvSpPr>
-          <p:cNvPr id="12" name="TextBox 11"/>
+          <p:cNvPr id="21" name="TextBox 20"/>
           <p:cNvSpPr txBox="1"/>
           <p:nvPr/>
         </p:nvSpPr>
@@ -13142,7 +13450,7 @@
       </p:sp>
       <p:sp>
         <p:nvSpPr>
-          <p:cNvPr id="13" name="TextBox 12"/>
+          <p:cNvPr id="22" name="TextBox 21"/>
           <p:cNvSpPr txBox="1"/>
           <p:nvPr/>
         </p:nvSpPr>

</xml_diff>